<commit_message>
Tighten slide 06 into actual bullets
The bullets had grown into paragraphs wearing bullet points -- the last one
ran to 52 words, which is a paragraph read aloud, not something a panel can
take in off a screen. Each is now one line.

The three figures it buried in prose (19,009 mentions, 2,014 people, 19.8
hours) move into the stat row, which is the deck's own device for numbers and
lands harder than reading them out mid-sentence. The caveat lost about a third
of its length without dropping anything it said.

Regenerating the PDF also caught a process defect worth recording: a
soffice --convert-to run can return silently without writing, and the previous
step copied the stale file over the new one. The export is verified by reading
the rendered page now, not by assuming the command worked.

Co-Authored-By: Claude Opus 5 <noreply@anthropic.com>
</commit_message>
<xml_diff>
--- a/presos/Graph_RAG_Interview_Deck.pptx
+++ b/presos/Graph_RAG_Interview_Deck.pptx
@@ -10155,7 +10155,7 @@
         <p:spPr>
           <a:xfrm>
             <a:off x="566928" y="1600200"/>
-            <a:ext cx="11057839" cy="5105400"/>
+            <a:ext cx="11057839" cy="4901183"/>
           </a:xfrm>
           <a:prstGeom prst="rect">
             <a:avLst/>
@@ -10221,7 +10221,7 @@
                 </a:solidFill>
                 <a:latin typeface="Helvetica Neue"/>
               </a:rPr>
-              <a:t>•  It groups the graph into topics and writes a report on each one. Global Search reads those reports instead of walking the graph.</a:t>
+              <a:t>•  Groups the graph into topics, and writes a report on each.</a:t>
             </a:r>
           </a:p>
           <a:p>
@@ -10259,7 +10259,7 @@
                 </a:solidFill>
                 <a:latin typeface="Helvetica Neue"/>
               </a:rPr>
-              <a:t>•  Those topic reports quietly absorb duplicate names. Two spellings of one person land in the same topic, so the report describes them as one person without anyone resolving anything.</a:t>
+              <a:t>•  Those reports absorb duplicate names on their own.</a:t>
             </a:r>
           </a:p>
           <a:p>
@@ -10278,7 +10278,7 @@
                 </a:solidFill>
                 <a:latin typeface="Georgia"/>
               </a:rPr>
-              <a:t>In other words: on well-named documents, the duplicate problem largely solves itself.</a:t>
+              <a:t>In other words: on well-named documents, the problem mostly solves itself.</a:t>
             </a:r>
           </a:p>
           <a:p>
@@ -10297,7 +10297,7 @@
                 </a:solidFill>
                 <a:latin typeface="Helvetica Neue"/>
               </a:rPr>
-              <a:t>•  That suits precise material — documentation, reports, structured filings, where a name is introduced once and then repeated exactly.</a:t>
+              <a:t>•  Best on precise material — documentation, reports, structured filings.</a:t>
             </a:r>
           </a:p>
           <a:p>
@@ -10316,7 +10316,7 @@
                 </a:solidFill>
                 <a:latin typeface="Georgia"/>
               </a:rPr>
-              <a:t>In other words: most business content is written this way, so it is a sensible thing to build for.</a:t>
+              <a:t>In other words: most business content is written this way.</a:t>
             </a:r>
           </a:p>
           <a:p>
@@ -10354,7 +10354,7 @@
                 </a:solidFill>
                 <a:latin typeface="Helvetica Neue"/>
               </a:rPr>
-              <a:t>•  That absorption stops at Local Search. Anchor on one of two nodes for the same person and you walk half their connections — with full confidence and no sign anything is missing.</a:t>
+              <a:t>•  That absorption stops at Local Search. Two nodes for one person, half the connections, no warning.</a:t>
             </a:r>
           </a:p>
           <a:p>
@@ -10373,7 +10373,7 @@
                 </a:solidFill>
                 <a:latin typeface="Georgia"/>
               </a:rPr>
-              <a:t>In other words: the answer looks complete when it is not, and nothing tells you.</a:t>
+              <a:t>In other words: the answer looks complete when it is not.</a:t>
             </a:r>
           </a:p>
           <a:p>
@@ -10392,7 +10392,7 @@
                 </a:solidFill>
                 <a:latin typeface="Helvetica Neue"/>
               </a:rPr>
-              <a:t>•  My documents name people loosely. The same man is RECAREY, JOSEPH in a caption, Det. Recarey in a transcript and Mr. Recarey in a brief — different spellings, mixed upper and lower case, honorifics, initials, maiden names, all inside one docket. So I added a step that works out which names refer to the same person: 19,009 mentions down to 2,014 people, 19.8 hours, the most expensive stage in the build.</a:t>
+              <a:t>•  My documents name people loosely. RECAREY, JOSEPH · Det. Recarey · Mr. Recarey — one man, one docket.</a:t>
             </a:r>
           </a:p>
           <a:p>
@@ -10417,6 +10417,90 @@
           <a:p>
             <a:pPr>
               <a:spcBef>
+                <a:spcPts val="600"/>
+              </a:spcBef>
+              <a:spcAft>
+                <a:spcPts val="200"/>
+              </a:spcAft>
+            </a:pPr>
+            <a:r>
+              <a:rPr sz="2000" b="1" i="0">
+                <a:solidFill>
+                  <a:srgbClr val="1E3A5F"/>
+                </a:solidFill>
+                <a:latin typeface="Georgia"/>
+              </a:rPr>
+              <a:t>19,009   </a:t>
+            </a:r>
+            <a:r>
+              <a:rPr sz="1000" b="0" i="0">
+                <a:solidFill>
+                  <a:srgbClr val="838B93"/>
+                </a:solidFill>
+                <a:latin typeface="Helvetica Neue"/>
+              </a:rPr>
+              <a:t>MENTIONS</a:t>
+            </a:r>
+          </a:p>
+          <a:p>
+            <a:pPr>
+              <a:spcBef>
+                <a:spcPts val="600"/>
+              </a:spcBef>
+              <a:spcAft>
+                <a:spcPts val="200"/>
+              </a:spcAft>
+            </a:pPr>
+            <a:r>
+              <a:rPr sz="2000" b="1" i="0">
+                <a:solidFill>
+                  <a:srgbClr val="1E3A5F"/>
+                </a:solidFill>
+                <a:latin typeface="Georgia"/>
+              </a:rPr>
+              <a:t>2,014   </a:t>
+            </a:r>
+            <a:r>
+              <a:rPr sz="1000" b="0" i="0">
+                <a:solidFill>
+                  <a:srgbClr val="838B93"/>
+                </a:solidFill>
+                <a:latin typeface="Helvetica Neue"/>
+              </a:rPr>
+              <a:t>ACTUAL PEOPLE</a:t>
+            </a:r>
+          </a:p>
+          <a:p>
+            <a:pPr>
+              <a:spcBef>
+                <a:spcPts val="600"/>
+              </a:spcBef>
+              <a:spcAft>
+                <a:spcPts val="200"/>
+              </a:spcAft>
+            </a:pPr>
+            <a:r>
+              <a:rPr sz="2000" b="1" i="0">
+                <a:solidFill>
+                  <a:srgbClr val="1E3A5F"/>
+                </a:solidFill>
+                <a:latin typeface="Georgia"/>
+              </a:rPr>
+              <a:t>19.8h   </a:t>
+            </a:r>
+            <a:r>
+              <a:rPr sz="1000" b="0" i="0">
+                <a:solidFill>
+                  <a:srgbClr val="838B93"/>
+                </a:solidFill>
+                <a:latin typeface="Helvetica Neue"/>
+              </a:rPr>
+              <a:t>THE MOST EXPENSIVE STAGE</a:t>
+            </a:r>
+          </a:p>
+          <a:p>
+            <a:pPr>
+              <a:spcBef>
                 <a:spcPts val="700"/>
               </a:spcBef>
               <a:spcAft>
@@ -10430,7 +10514,7 @@
                 </a:solidFill>
                 <a:latin typeface="Helvetica Neue"/>
               </a:rPr>
-              <a:t>Said carefully: I may well have missed something. I read their published documentation, not their source, and I did not test the product. Their docs do not describe an identity-resolution step, but that is an argument from silence — they may already handle this. The fair question is on their own ground, not mine: how does the Importer handle k8s versus Kubernetes, or AWS versus Amazon Web Services? Acronym expansion is the same problem.</a:t>
+              <a:t>Said carefully: I read their published documentation, not their source, and I did not test the product. Their docs describe no identity-resolution step, but that is an argument from silence. The fair question is on their ground, not mine: how does the Importer handle k8s versus Kubernetes?</a:t>
             </a:r>
           </a:p>
           <a:p>

</xml_diff>

<commit_message>
Drop the "in other words" lead-in from every restatement line
The phrase appeared on all 16 restatement lines. The indent and the italic
already mark that line as the plain-language version of the bullet above it,
so the words were doing no work and read as padding by the third slide.

Sentences are unchanged apart from capitalising the first letter.

Co-Authored-By: Claude Opus 5 <noreply@anthropic.com>
</commit_message>
<xml_diff>
--- a/presos/Graph_RAG_Interview_Deck.pptx
+++ b/presos/Graph_RAG_Interview_Deck.pptx
@@ -8026,7 +8026,7 @@
                 </a:solidFill>
                 <a:latin typeface="Georgia"/>
               </a:rPr>
-              <a:t>In other words: you can redraw the map without touching the thing your users talk to.</a:t>
+              <a:t>You can redraw the map without touching the thing your users talk to.</a:t>
             </a:r>
           </a:p>
           <a:p>
@@ -8064,7 +8064,7 @@
                 </a:solidFill>
                 <a:latin typeface="Georgia"/>
               </a:rPr>
-              <a:t>In other words: it reads everything once, so nobody on your team has to read it again.</a:t>
+              <a:t>It reads everything once, so nobody on your team has to read it again.</a:t>
             </a:r>
           </a:p>
           <a:p>
@@ -8102,7 +8102,7 @@
                 </a:solidFill>
                 <a:latin typeface="Georgia"/>
               </a:rPr>
-              <a:t>In other words: a person can check the work — which is the difference between a tool a regulated business can use and one it cannot.</a:t>
+              <a:t>A person can check the work — which is the difference between a tool a regulated business can use and one it cannot.</a:t>
             </a:r>
           </a:p>
           <a:p>
@@ -8140,7 +8140,7 @@
                 </a:solidFill>
                 <a:latin typeface="Georgia"/>
               </a:rPr>
-              <a:t>In other words: nothing leaves the building, and one database replaces three to secure and staff.</a:t>
+              <a:t>Nothing leaves the building, and one database replaces three to secure and staff.</a:t>
             </a:r>
           </a:p>
           <a:p>
@@ -8846,7 +8846,7 @@
         <p:spPr>
           <a:xfrm>
             <a:off x="566928" y="4222496"/>
-            <a:ext cx="11057839" cy="1572768"/>
+            <a:ext cx="11057839" cy="1374648"/>
           </a:xfrm>
           <a:prstGeom prst="rect">
             <a:avLst/>
@@ -8893,7 +8893,7 @@
                 </a:solidFill>
                 <a:latin typeface="Georgia"/>
               </a:rPr>
-              <a:t>In other words: "what is actually in here?" — the first thing anyone asks, and the one thing ordinary search cannot do.</a:t>
+              <a:t>"what is actually in here?" — the first thing anyone asks, and the one thing ordinary search cannot do.</a:t>
             </a:r>
           </a:p>
           <a:p>
@@ -8931,7 +8931,7 @@
                 </a:solidFill>
                 <a:latin typeface="Georgia"/>
               </a:rPr>
-              <a:t>In other words: this is where my design stops and theirs keeps going. I would rather show you the gap than hide it.</a:t>
+              <a:t>This is where my design stops and theirs keeps going. I would rather show you the gap than hide it.</a:t>
             </a:r>
           </a:p>
         </p:txBody>
@@ -10155,7 +10155,7 @@
         <p:spPr>
           <a:xfrm>
             <a:off x="566928" y="1600200"/>
-            <a:ext cx="11057839" cy="4901183"/>
+            <a:ext cx="11057839" cy="4703063"/>
           </a:xfrm>
           <a:prstGeom prst="rect">
             <a:avLst/>
@@ -10240,7 +10240,7 @@
                 </a:solidFill>
                 <a:latin typeface="Georgia"/>
               </a:rPr>
-              <a:t>In other words: it can describe a whole collection, not just find a passage in it.</a:t>
+              <a:t>It can describe a whole collection, not just find a passage in it.</a:t>
             </a:r>
           </a:p>
           <a:p>
@@ -10278,7 +10278,7 @@
                 </a:solidFill>
                 <a:latin typeface="Georgia"/>
               </a:rPr>
-              <a:t>In other words: on well-named documents, the problem mostly solves itself.</a:t>
+              <a:t>On well-named documents, the problem mostly solves itself.</a:t>
             </a:r>
           </a:p>
           <a:p>
@@ -10316,7 +10316,7 @@
                 </a:solidFill>
                 <a:latin typeface="Georgia"/>
               </a:rPr>
-              <a:t>In other words: most business content is written this way.</a:t>
+              <a:t>Most business content is written this way.</a:t>
             </a:r>
           </a:p>
           <a:p>
@@ -10373,7 +10373,7 @@
                 </a:solidFill>
                 <a:latin typeface="Georgia"/>
               </a:rPr>
-              <a:t>In other words: the answer looks complete when it is not.</a:t>
+              <a:t>The answer looks complete when it is not.</a:t>
             </a:r>
           </a:p>
           <a:p>
@@ -10411,7 +10411,7 @@
                 </a:solidFill>
                 <a:latin typeface="Georgia"/>
               </a:rPr>
-              <a:t>In other words: documents that name things consistently never need this step.</a:t>
+              <a:t>Documents that name things consistently never need this step.</a:t>
             </a:r>
           </a:p>
           <a:p>
@@ -11057,7 +11057,7 @@
         <p:spPr>
           <a:xfrm>
             <a:off x="566928" y="1600200"/>
-            <a:ext cx="11057839" cy="4352036"/>
+            <a:ext cx="11057839" cy="4153915"/>
           </a:xfrm>
           <a:prstGeom prst="rect">
             <a:avLst/>
@@ -11123,7 +11123,7 @@
                 </a:solidFill>
                 <a:latin typeface="Georgia"/>
               </a:rPr>
-              <a:t>In other words: a whole class of bug — the two stores quietly disagreeing — stops existing, and a join across two systems becomes one lookup.</a:t>
+              <a:t>A whole class of bug — the two stores quietly disagreeing — stops existing, and a join across two systems becomes one lookup.</a:t>
             </a:r>
           </a:p>
           <a:p>
@@ -11161,7 +11161,7 @@
                 </a:solidFill>
                 <a:latin typeface="Georgia"/>
               </a:rPr>
-              <a:t>In other words: one client's documents stay in one place — faster to query, and far easier to explain to their auditor.</a:t>
+              <a:t>One client's documents stay in one place — faster to query, and far easier to explain to their auditor.</a:t>
             </a:r>
           </a:p>
           <a:p>
@@ -11199,7 +11199,7 @@
                 </a:solidFill>
                 <a:latin typeface="Georgia"/>
               </a:rPr>
-              <a:t>In other words: don't make the most-used lookup in the system take a network hop.</a:t>
+              <a:t>Don't make the most-used lookup in the system take a network hop.</a:t>
             </a:r>
           </a:p>
           <a:p>
@@ -11237,7 +11237,7 @@
                 </a:solidFill>
                 <a:latin typeface="Georgia"/>
               </a:rPr>
-              <a:t>In other words: I would rather miss a link than invent one — and someone has to be paid to make that call.</a:t>
+              <a:t>I would rather miss a link than invent one — and someone has to be paid to make that call.</a:t>
             </a:r>
           </a:p>
           <a:p>
@@ -11275,7 +11275,7 @@
                 </a:solidFill>
                 <a:latin typeface="Georgia"/>
               </a:rPr>
-              <a:t>In other words: today, one new filing means redoing the whole graph. That is the hard problem, and I have not solved it.</a:t>
+              <a:t>Today, one new filing means redoing the whole graph. That is the hard problem, and I have not solved it.</a:t>
             </a:r>
           </a:p>
           <a:p>

</xml_diff>